<commit_message>
Address review: use design tokens; fix palette cycling
- 05_cybersecurity_briefing: replace hardcoded severity hex values
  with TOKENS.palette["negative"|"accent"|"positive"] so the colors
  stay theme-driven.
- 10_marketing_campaign: _channel_mix has 7 categories but PALETTE
  has 6, so zip() left the 7th data point uncolored. Switch to a
  modulo-based loop so the palette cycles.

https://claude.ai/code/session_012gX4Kv5LjTEL2qonW8KYgC
</commit_message>
<xml_diff>
--- a/examples/real_world/_out/10_marketing_campaign.pptx
+++ b/examples/real_world/_out/10_marketing_campaign.pptx
@@ -360,6 +360,14 @@
             <c:spPr>
               <a:solidFill>
                 <a:srgbClr val="3B82F6"/>
+              </a:solidFill>
+            </c:spPr>
+          </c:dPt>
+          <c:dPt>
+            <c:idx val="6"/>
+            <c:spPr>
+              <a:solidFill>
+                <a:srgbClr val="DB2777"/>
               </a:solidFill>
             </c:spPr>
           </c:dPt>

</xml_diff>